<commit_message>
Quartz sync: Aug 25, 2026, 6:47 PM
</commit_message>
<xml_diff>
--- a/content/Articles/session52tokens.pptx
+++ b/content/Articles/session52tokens.pptx
@@ -116,7 +116,7 @@
 <file path=ppt/revisionInfo.xml><?xml version="1.0" encoding="utf-8"?>
 <p1510:revInfo xmlns:a="http://schemas.openxmlformats.org/drawingml/2006/main" xmlns:r="http://schemas.openxmlformats.org/officeDocument/2006/relationships" xmlns:p1510="http://schemas.microsoft.com/office/powerpoint/2015/10/main">
   <p1510:revLst>
-    <p1510:client id="{9AC4FC32-EA96-44B4-96C1-E3A4EF7EDEF6}" v="12" dt="2026-08-02T22:18:39.620"/>
+    <p1510:client id="{9AC4FC32-EA96-44B4-96C1-E3A4EF7EDEF6}" v="16" dt="2026-08-02T22:58:03.691"/>
   </p1510:revLst>
 </p1510:revInfo>
 </file>
@@ -126,7 +126,7 @@
   <pc:docChgLst>
     <pc:chgData name="Jack Bond" userId="d0613b4d9d68792d" providerId="LiveId" clId="{DAEA3D54-AD02-4E1B-A73A-AB467D915B21}"/>
     <pc:docChg chg="undo custSel addSld delSld modSld sldOrd">
-      <pc:chgData name="Jack Bond" userId="d0613b4d9d68792d" providerId="LiveId" clId="{DAEA3D54-AD02-4E1B-A73A-AB467D915B21}" dt="2026-08-02T22:18:39.620" v="1607"/>
+      <pc:chgData name="Jack Bond" userId="d0613b4d9d68792d" providerId="LiveId" clId="{DAEA3D54-AD02-4E1B-A73A-AB467D915B21}" dt="2026-08-02T22:58:12.053" v="1621" actId="1076"/>
       <pc:docMkLst>
         <pc:docMk/>
       </pc:docMkLst>
@@ -178,7 +178,7 @@
         </pc:picChg>
       </pc:sldChg>
       <pc:sldChg chg="addSp delSp modSp new mod">
-        <pc:chgData name="Jack Bond" userId="d0613b4d9d68792d" providerId="LiveId" clId="{DAEA3D54-AD02-4E1B-A73A-AB467D915B21}" dt="2026-08-02T22:18:39.620" v="1607"/>
+        <pc:chgData name="Jack Bond" userId="d0613b4d9d68792d" providerId="LiveId" clId="{DAEA3D54-AD02-4E1B-A73A-AB467D915B21}" dt="2026-08-02T22:58:12.053" v="1621" actId="1076"/>
         <pc:sldMkLst>
           <pc:docMk/>
           <pc:sldMk cId="2910099394" sldId="278"/>
@@ -191,8 +191,16 @@
             <ac:grpSpMk id="6" creationId="{A8690CF8-B6CC-2D74-1C44-29B3A61276DB}"/>
           </ac:grpSpMkLst>
         </pc:grpChg>
+        <pc:grpChg chg="add mod">
+          <ac:chgData name="Jack Bond" userId="d0613b4d9d68792d" providerId="LiveId" clId="{DAEA3D54-AD02-4E1B-A73A-AB467D915B21}" dt="2026-08-02T22:58:12.053" v="1621" actId="1076"/>
+          <ac:grpSpMkLst>
+            <pc:docMk/>
+            <pc:sldMk cId="2910099394" sldId="278"/>
+            <ac:grpSpMk id="11" creationId="{36B21515-AECC-215C-8584-AEAD2815D4AD}"/>
+          </ac:grpSpMkLst>
+        </pc:grpChg>
         <pc:picChg chg="add mod topLvl">
-          <ac:chgData name="Jack Bond" userId="d0613b4d9d68792d" providerId="LiveId" clId="{DAEA3D54-AD02-4E1B-A73A-AB467D915B21}" dt="2026-08-02T22:18:35.136" v="1605"/>
+          <ac:chgData name="Jack Bond" userId="d0613b4d9d68792d" providerId="LiveId" clId="{DAEA3D54-AD02-4E1B-A73A-AB467D915B21}" dt="2026-08-02T22:58:03.690" v="1617" actId="164"/>
           <ac:picMkLst>
             <pc:docMk/>
             <pc:sldMk cId="2910099394" sldId="278"/>
@@ -200,7 +208,7 @@
           </ac:picMkLst>
         </pc:picChg>
         <pc:picChg chg="add mod topLvl">
-          <ac:chgData name="Jack Bond" userId="d0613b4d9d68792d" providerId="LiveId" clId="{DAEA3D54-AD02-4E1B-A73A-AB467D915B21}" dt="2026-08-02T22:18:39.620" v="1607"/>
+          <ac:chgData name="Jack Bond" userId="d0613b4d9d68792d" providerId="LiveId" clId="{DAEA3D54-AD02-4E1B-A73A-AB467D915B21}" dt="2026-08-02T22:58:03.690" v="1617" actId="164"/>
           <ac:picMkLst>
             <pc:docMk/>
             <pc:sldMk cId="2910099394" sldId="278"/>
@@ -213,6 +221,14 @@
             <pc:docMk/>
             <pc:sldMk cId="2910099394" sldId="278"/>
             <ac:picMk id="8" creationId="{E426A030-FB7F-9F16-2BCE-2348017A08F8}"/>
+          </ac:picMkLst>
+        </pc:picChg>
+        <pc:picChg chg="add mod">
+          <ac:chgData name="Jack Bond" userId="d0613b4d9d68792d" providerId="LiveId" clId="{DAEA3D54-AD02-4E1B-A73A-AB467D915B21}" dt="2026-08-02T22:58:03.690" v="1617" actId="164"/>
+          <ac:picMkLst>
+            <pc:docMk/>
+            <pc:sldMk cId="2910099394" sldId="278"/>
+            <ac:picMk id="10" creationId="{190373A0-CF61-FE30-4AD7-DFB72383376A}"/>
           </ac:picMkLst>
         </pc:picChg>
       </pc:sldChg>
@@ -3214,104 +3230,174 @@
           <a:chExt cx="0" cy="0"/>
         </a:xfrm>
       </p:grpSpPr>
-      <p:pic>
-        <p:nvPicPr>
-          <p:cNvPr id="3" name="Picture 2">
+      <p:grpSp>
+        <p:nvGrpSpPr>
+          <p:cNvPr id="11" name="Group 10">
             <a:extLst>
               <a:ext uri="{FF2B5EF4-FFF2-40B4-BE49-F238E27FC236}">
-                <a16:creationId xmlns:a16="http://schemas.microsoft.com/office/drawing/2014/main" id="{D358F318-79B8-E3B7-F1BC-B0A4012D3D35}"/>
+                <a16:creationId xmlns:a16="http://schemas.microsoft.com/office/drawing/2014/main" id="{36B21515-AECC-215C-8584-AEAD2815D4AD}"/>
               </a:ext>
             </a:extLst>
           </p:cNvPr>
-          <p:cNvPicPr>
-            <a:picLocks noChangeAspect="1"/>
-          </p:cNvPicPr>
+          <p:cNvGrpSpPr/>
           <p:nvPr/>
-        </p:nvPicPr>
-        <p:blipFill>
-          <a:blip r:embed="rId2">
-            <a:biLevel thresh="75000"/>
-            <a:extLst>
-              <a:ext uri="{BEBA8EAE-BF5A-486C-A8C5-ECC9F3942E4B}">
-                <a14:imgProps xmlns:a14="http://schemas.microsoft.com/office/drawing/2010/main">
-                  <a14:imgLayer r:embed="rId3">
-                    <a14:imgEffect>
-                      <a14:sharpenSoften amount="50000"/>
-                    </a14:imgEffect>
-                    <a14:imgEffect>
-                      <a14:brightnessContrast bright="40000" contrast="20000"/>
-                    </a14:imgEffect>
-                  </a14:imgLayer>
-                </a14:imgProps>
-              </a:ext>
-              <a:ext uri="{28A0092B-C50C-407E-A947-70E740481C1C}">
-                <a14:useLocalDpi xmlns:a14="http://schemas.microsoft.com/office/drawing/2010/main" val="0"/>
-              </a:ext>
-            </a:extLst>
-          </a:blip>
-          <a:stretch>
-            <a:fillRect/>
-          </a:stretch>
-        </p:blipFill>
-        <p:spPr>
+        </p:nvGrpSpPr>
+        <p:grpSpPr>
           <a:xfrm>
-            <a:off x="449727" y="1529385"/>
-            <a:ext cx="3512439" cy="4864728"/>
+            <a:off x="672124" y="1147505"/>
+            <a:ext cx="6428151" cy="8711821"/>
+            <a:chOff x="449727" y="575229"/>
+            <a:chExt cx="7024878" cy="9520542"/>
           </a:xfrm>
-          <a:prstGeom prst="rect">
-            <a:avLst/>
-          </a:prstGeom>
-        </p:spPr>
-      </p:pic>
-      <p:pic>
-        <p:nvPicPr>
-          <p:cNvPr id="5" name="Picture 4">
-            <a:extLst>
-              <a:ext uri="{FF2B5EF4-FFF2-40B4-BE49-F238E27FC236}">
-                <a16:creationId xmlns:a16="http://schemas.microsoft.com/office/drawing/2014/main" id="{30C5D1A7-117C-67CA-F01C-80C3BE6B2CEA}"/>
-              </a:ext>
-            </a:extLst>
-          </p:cNvPr>
-          <p:cNvPicPr>
-            <a:picLocks noChangeAspect="1"/>
-          </p:cNvPicPr>
-          <p:nvPr/>
-        </p:nvPicPr>
-        <p:blipFill>
-          <a:blip r:embed="rId4">
-            <a:biLevel thresh="75000"/>
-            <a:extLst>
-              <a:ext uri="{BEBA8EAE-BF5A-486C-A8C5-ECC9F3942E4B}">
-                <a14:imgProps xmlns:a14="http://schemas.microsoft.com/office/drawing/2010/main">
-                  <a14:imgLayer r:embed="rId5">
-                    <a14:imgEffect>
-                      <a14:sharpenSoften amount="50000"/>
-                    </a14:imgEffect>
-                    <a14:imgEffect>
-                      <a14:brightnessContrast bright="40000" contrast="20000"/>
-                    </a14:imgEffect>
-                  </a14:imgLayer>
-                </a14:imgProps>
-              </a:ext>
-              <a:ext uri="{28A0092B-C50C-407E-A947-70E740481C1C}">
-                <a14:useLocalDpi xmlns:a14="http://schemas.microsoft.com/office/drawing/2010/main" val="0"/>
-              </a:ext>
-            </a:extLst>
-          </a:blip>
-          <a:stretch>
-            <a:fillRect/>
-          </a:stretch>
-        </p:blipFill>
-        <p:spPr>
-          <a:xfrm>
-            <a:off x="3962166" y="1529385"/>
-            <a:ext cx="3512439" cy="5215972"/>
-          </a:xfrm>
-          <a:prstGeom prst="rect">
-            <a:avLst/>
-          </a:prstGeom>
-        </p:spPr>
-      </p:pic>
+        </p:grpSpPr>
+        <p:pic>
+          <p:nvPicPr>
+            <p:cNvPr id="3" name="Picture 2">
+              <a:extLst>
+                <a:ext uri="{FF2B5EF4-FFF2-40B4-BE49-F238E27FC236}">
+                  <a16:creationId xmlns:a16="http://schemas.microsoft.com/office/drawing/2014/main" id="{D358F318-79B8-E3B7-F1BC-B0A4012D3D35}"/>
+                </a:ext>
+              </a:extLst>
+            </p:cNvPr>
+            <p:cNvPicPr>
+              <a:picLocks noChangeAspect="1"/>
+            </p:cNvPicPr>
+            <p:nvPr/>
+          </p:nvPicPr>
+          <p:blipFill>
+            <a:blip r:embed="rId2">
+              <a:biLevel thresh="75000"/>
+              <a:extLst>
+                <a:ext uri="{BEBA8EAE-BF5A-486C-A8C5-ECC9F3942E4B}">
+                  <a14:imgProps xmlns:a14="http://schemas.microsoft.com/office/drawing/2010/main">
+                    <a14:imgLayer r:embed="rId3">
+                      <a14:imgEffect>
+                        <a14:sharpenSoften amount="50000"/>
+                      </a14:imgEffect>
+                      <a14:imgEffect>
+                        <a14:brightnessContrast bright="40000" contrast="20000"/>
+                      </a14:imgEffect>
+                    </a14:imgLayer>
+                  </a14:imgProps>
+                </a:ext>
+                <a:ext uri="{28A0092B-C50C-407E-A947-70E740481C1C}">
+                  <a14:useLocalDpi xmlns:a14="http://schemas.microsoft.com/office/drawing/2010/main" val="0"/>
+                </a:ext>
+              </a:extLst>
+            </a:blip>
+            <a:stretch>
+              <a:fillRect/>
+            </a:stretch>
+          </p:blipFill>
+          <p:spPr>
+            <a:xfrm>
+              <a:off x="449727" y="575229"/>
+              <a:ext cx="3512439" cy="4864728"/>
+            </a:xfrm>
+            <a:prstGeom prst="rect">
+              <a:avLst/>
+            </a:prstGeom>
+          </p:spPr>
+        </p:pic>
+        <p:pic>
+          <p:nvPicPr>
+            <p:cNvPr id="5" name="Picture 4">
+              <a:extLst>
+                <a:ext uri="{FF2B5EF4-FFF2-40B4-BE49-F238E27FC236}">
+                  <a16:creationId xmlns:a16="http://schemas.microsoft.com/office/drawing/2014/main" id="{30C5D1A7-117C-67CA-F01C-80C3BE6B2CEA}"/>
+                </a:ext>
+              </a:extLst>
+            </p:cNvPr>
+            <p:cNvPicPr>
+              <a:picLocks noChangeAspect="1"/>
+            </p:cNvPicPr>
+            <p:nvPr/>
+          </p:nvPicPr>
+          <p:blipFill>
+            <a:blip r:embed="rId4">
+              <a:biLevel thresh="75000"/>
+              <a:extLst>
+                <a:ext uri="{BEBA8EAE-BF5A-486C-A8C5-ECC9F3942E4B}">
+                  <a14:imgProps xmlns:a14="http://schemas.microsoft.com/office/drawing/2010/main">
+                    <a14:imgLayer r:embed="rId5">
+                      <a14:imgEffect>
+                        <a14:sharpenSoften amount="50000"/>
+                      </a14:imgEffect>
+                      <a14:imgEffect>
+                        <a14:brightnessContrast bright="40000" contrast="20000"/>
+                      </a14:imgEffect>
+                    </a14:imgLayer>
+                  </a14:imgProps>
+                </a:ext>
+                <a:ext uri="{28A0092B-C50C-407E-A947-70E740481C1C}">
+                  <a14:useLocalDpi xmlns:a14="http://schemas.microsoft.com/office/drawing/2010/main" val="0"/>
+                </a:ext>
+              </a:extLst>
+            </a:blip>
+            <a:stretch>
+              <a:fillRect/>
+            </a:stretch>
+          </p:blipFill>
+          <p:spPr>
+            <a:xfrm>
+              <a:off x="3962166" y="575229"/>
+              <a:ext cx="3512439" cy="5215972"/>
+            </a:xfrm>
+            <a:prstGeom prst="rect">
+              <a:avLst/>
+            </a:prstGeom>
+          </p:spPr>
+        </p:pic>
+        <p:pic>
+          <p:nvPicPr>
+            <p:cNvPr id="10" name="Picture 9">
+              <a:extLst>
+                <a:ext uri="{FF2B5EF4-FFF2-40B4-BE49-F238E27FC236}">
+                  <a16:creationId xmlns:a16="http://schemas.microsoft.com/office/drawing/2014/main" id="{190373A0-CF61-FE30-4AD7-DFB72383376A}"/>
+                </a:ext>
+              </a:extLst>
+            </p:cNvPr>
+            <p:cNvPicPr>
+              <a:picLocks noChangeAspect="1"/>
+            </p:cNvPicPr>
+            <p:nvPr/>
+          </p:nvPicPr>
+          <p:blipFill>
+            <a:blip r:embed="rId6">
+              <a:biLevel thresh="75000"/>
+              <a:extLst>
+                <a:ext uri="{BEBA8EAE-BF5A-486C-A8C5-ECC9F3942E4B}">
+                  <a14:imgProps xmlns:a14="http://schemas.microsoft.com/office/drawing/2010/main">
+                    <a14:imgLayer r:embed="rId7">
+                      <a14:imgEffect>
+                        <a14:sharpenSoften amount="50000"/>
+                      </a14:imgEffect>
+                      <a14:imgEffect>
+                        <a14:brightnessContrast bright="40000" contrast="40000"/>
+                      </a14:imgEffect>
+                    </a14:imgLayer>
+                  </a14:imgProps>
+                </a:ext>
+                <a:ext uri="{28A0092B-C50C-407E-A947-70E740481C1C}">
+                  <a14:useLocalDpi xmlns:a14="http://schemas.microsoft.com/office/drawing/2010/main" val="0"/>
+                </a:ext>
+              </a:extLst>
+            </a:blip>
+            <a:stretch>
+              <a:fillRect/>
+            </a:stretch>
+          </p:blipFill>
+          <p:spPr>
+            <a:xfrm>
+              <a:off x="449727" y="5731566"/>
+              <a:ext cx="7024878" cy="4364205"/>
+            </a:xfrm>
+            <a:prstGeom prst="rect">
+              <a:avLst/>
+            </a:prstGeom>
+          </p:spPr>
+        </p:pic>
+      </p:grpSp>
     </p:spTree>
     <p:extLst>
       <p:ext uri="{BB962C8B-B14F-4D97-AF65-F5344CB8AC3E}">

</xml_diff>